<commit_message>
Fixeep RRSS pptx para Canva
</commit_message>
<xml_diff>
--- a/Campanas/Fixeep - Dia del Padre 1x1.pptx
+++ b/Campanas/Fixeep - Dia del Padre 1x1.pptx
@@ -3112,8 +3112,8 @@
         </p:blipFill>
         <p:spPr>
           <a:xfrm>
-            <a:off x="0" y="-3200400"/>
-            <a:ext cx="8229600" cy="14630400"/>
+            <a:off x="0" y="-1371600"/>
+            <a:ext cx="8229600" cy="10972800"/>
           </a:xfrm>
           <a:prstGeom prst="rect">
             <a:avLst/>

</xml_diff>